<commit_message>
feat: add ResNet18 & YOLO comparisons to evaluation + PPT
Extended evaluation results:
- ResNet18 Classifier: 99.69% acc but 6.1s retrain time
- YOLOv8: ~95-98% (est.), ~5 min retrain
- Our kNN: 97.19% acc, 0.48ms retrain (12,760x faster than ResNet)

PPT now includes 6-model comparison in metrics slides
</commit_message>
<xml_diff>
--- a/arc-project/Retail_Checkout_Phase2_Presentation.pptx
+++ b/arc-project/Retail_Checkout_Phase2_Presentation.pptx
@@ -4735,7 +4735,7 @@
                 <a:gridCol w="1280160"/>
                 <a:gridCol w="1188720"/>
               </a:tblGrid>
-              <a:tr h="457200">
+              <a:tr h="326571">
                 <a:tc>
                   <a:txBody>
                     <a:bodyPr/>
@@ -5077,7 +5077,7 @@
                   </a:tcPr>
                 </a:tc>
               </a:tr>
-              <a:tr h="457200">
+              <a:tr h="326571">
                 <a:tc>
                   <a:txBody>
                     <a:bodyPr/>
@@ -5419,7 +5419,7 @@
                   </a:tcPr>
                 </a:tc>
               </a:tr>
-              <a:tr h="457200">
+              <a:tr h="326571">
                 <a:tc>
                   <a:txBody>
                     <a:bodyPr/>
@@ -5437,7 +5437,7 @@
                           <a:ea typeface="Calibri" pitchFamily="34" charset="-122"/>
                           <a:cs typeface="Calibri" pitchFamily="34" charset="-120"/>
                         </a:rPr>
-                        <a:t>SVM (RBF Kernel)</a:t>
+                        <a:t>ResNet18 Classifier (fine-tuned)</a:t>
                       </a:r>
                       <a:endParaRPr lang="en-US" sz="1400" dirty="0">
                         <a:latin typeface="Calibri" charset="0"/>
@@ -5761,7 +5761,349 @@
                   </a:tcPr>
                 </a:tc>
               </a:tr>
-              <a:tr h="457200">
+              <a:tr h="326571">
+                <a:tc>
+                  <a:txBody>
+                    <a:bodyPr/>
+                    <a:lstStyle/>
+                    <a:p>
+                      <a:pPr indent="0" marL="0">
+                        <a:buNone/>
+                      </a:pPr>
+                      <a:r>
+                        <a:rPr lang="en-US" sz="1400" dirty="0">
+                          <a:solidFill>
+                            <a:srgbClr val="E2E8F0"/>
+                          </a:solidFill>
+                          <a:latin typeface="Calibri" pitchFamily="34" charset="0"/>
+                          <a:ea typeface="Calibri" pitchFamily="34" charset="-122"/>
+                          <a:cs typeface="Calibri" pitchFamily="34" charset="-120"/>
+                        </a:rPr>
+                        <a:t>SVM (RBF Kernel)</a:t>
+                      </a:r>
+                      <a:endParaRPr lang="en-US" sz="1400" dirty="0">
+                        <a:latin typeface="Calibri" charset="0"/>
+                        <a:ea typeface="Calibri" charset="0"/>
+                        <a:cs typeface="Calibri" charset="0"/>
+                      </a:endParaRPr>
+                    </a:p>
+                  </a:txBody>
+                  <a:tcPr marL="91440" marR="91440" marT="45720" marB="45720" anchor="ctr">
+                    <a:lnL w="12700" cap="flat" cmpd="sng" algn="ctr">
+                      <a:solidFill>
+                        <a:srgbClr val="475569"/>
+                      </a:solidFill>
+                      <a:prstDash val="solid"/>
+                      <a:round/>
+                      <a:headEnd type="none" w="med" len="med"/>
+                      <a:tailEnd type="none" w="med" len="med"/>
+                    </a:lnL>
+                    <a:lnR w="12700" cap="flat" cmpd="sng" algn="ctr">
+                      <a:solidFill>
+                        <a:srgbClr val="475569"/>
+                      </a:solidFill>
+                      <a:prstDash val="solid"/>
+                      <a:round/>
+                      <a:headEnd type="none" w="med" len="med"/>
+                      <a:tailEnd type="none" w="med" len="med"/>
+                    </a:lnR>
+                    <a:lnT w="12700" cap="flat" cmpd="sng" algn="ctr">
+                      <a:solidFill>
+                        <a:srgbClr val="475569"/>
+                      </a:solidFill>
+                      <a:prstDash val="solid"/>
+                      <a:round/>
+                      <a:headEnd type="none" w="med" len="med"/>
+                      <a:tailEnd type="none" w="med" len="med"/>
+                    </a:lnT>
+                    <a:lnB w="12700" cap="flat" cmpd="sng" algn="ctr">
+                      <a:solidFill>
+                        <a:srgbClr val="475569"/>
+                      </a:solidFill>
+                      <a:prstDash val="solid"/>
+                      <a:round/>
+                      <a:headEnd type="none" w="med" len="med"/>
+                      <a:tailEnd type="none" w="med" len="med"/>
+                    </a:lnB>
+                    <a:solidFill>
+                      <a:srgbClr val="0F172A"/>
+                    </a:solidFill>
+                  </a:tcPr>
+                </a:tc>
+                <a:tc>
+                  <a:txBody>
+                    <a:bodyPr/>
+                    <a:lstStyle/>
+                    <a:p>
+                      <a:pPr algn="ctr" indent="0" marL="0">
+                        <a:buNone/>
+                      </a:pPr>
+                      <a:r>
+                        <a:rPr lang="en-US" sz="1400" dirty="0">
+                          <a:solidFill>
+                            <a:srgbClr val="E2E8F0"/>
+                          </a:solidFill>
+                          <a:latin typeface="Calibri" pitchFamily="34" charset="0"/>
+                          <a:ea typeface="Calibri" pitchFamily="34" charset="-122"/>
+                          <a:cs typeface="Calibri" pitchFamily="34" charset="-120"/>
+                        </a:rPr>
+                        <a:t>99.69%</a:t>
+                      </a:r>
+                      <a:endParaRPr lang="en-US" sz="1400" dirty="0">
+                        <a:latin typeface="Calibri" charset="0"/>
+                        <a:ea typeface="Calibri" charset="0"/>
+                        <a:cs typeface="Calibri" charset="0"/>
+                      </a:endParaRPr>
+                    </a:p>
+                  </a:txBody>
+                  <a:tcPr marL="91440" marR="91440" marT="45720" marB="45720" anchor="ctr">
+                    <a:lnL w="12700" cap="flat" cmpd="sng" algn="ctr">
+                      <a:solidFill>
+                        <a:srgbClr val="475569"/>
+                      </a:solidFill>
+                      <a:prstDash val="solid"/>
+                      <a:round/>
+                      <a:headEnd type="none" w="med" len="med"/>
+                      <a:tailEnd type="none" w="med" len="med"/>
+                    </a:lnL>
+                    <a:lnR w="12700" cap="flat" cmpd="sng" algn="ctr">
+                      <a:solidFill>
+                        <a:srgbClr val="475569"/>
+                      </a:solidFill>
+                      <a:prstDash val="solid"/>
+                      <a:round/>
+                      <a:headEnd type="none" w="med" len="med"/>
+                      <a:tailEnd type="none" w="med" len="med"/>
+                    </a:lnR>
+                    <a:lnT w="12700" cap="flat" cmpd="sng" algn="ctr">
+                      <a:solidFill>
+                        <a:srgbClr val="475569"/>
+                      </a:solidFill>
+                      <a:prstDash val="solid"/>
+                      <a:round/>
+                      <a:headEnd type="none" w="med" len="med"/>
+                      <a:tailEnd type="none" w="med" len="med"/>
+                    </a:lnT>
+                    <a:lnB w="12700" cap="flat" cmpd="sng" algn="ctr">
+                      <a:solidFill>
+                        <a:srgbClr val="475569"/>
+                      </a:solidFill>
+                      <a:prstDash val="solid"/>
+                      <a:round/>
+                      <a:headEnd type="none" w="med" len="med"/>
+                      <a:tailEnd type="none" w="med" len="med"/>
+                    </a:lnB>
+                    <a:solidFill>
+                      <a:srgbClr val="0F172A"/>
+                    </a:solidFill>
+                  </a:tcPr>
+                </a:tc>
+                <a:tc>
+                  <a:txBody>
+                    <a:bodyPr/>
+                    <a:lstStyle/>
+                    <a:p>
+                      <a:pPr algn="ctr" indent="0" marL="0">
+                        <a:buNone/>
+                      </a:pPr>
+                      <a:r>
+                        <a:rPr lang="en-US" sz="1400" dirty="0">
+                          <a:solidFill>
+                            <a:srgbClr val="E2E8F0"/>
+                          </a:solidFill>
+                          <a:latin typeface="Calibri" pitchFamily="34" charset="0"/>
+                          <a:ea typeface="Calibri" pitchFamily="34" charset="-122"/>
+                          <a:cs typeface="Calibri" pitchFamily="34" charset="-120"/>
+                        </a:rPr>
+                        <a:t>0.9970</a:t>
+                      </a:r>
+                      <a:endParaRPr lang="en-US" sz="1400" dirty="0">
+                        <a:latin typeface="Calibri" charset="0"/>
+                        <a:ea typeface="Calibri" charset="0"/>
+                        <a:cs typeface="Calibri" charset="0"/>
+                      </a:endParaRPr>
+                    </a:p>
+                  </a:txBody>
+                  <a:tcPr marL="91440" marR="91440" marT="45720" marB="45720" anchor="ctr">
+                    <a:lnL w="12700" cap="flat" cmpd="sng" algn="ctr">
+                      <a:solidFill>
+                        <a:srgbClr val="475569"/>
+                      </a:solidFill>
+                      <a:prstDash val="solid"/>
+                      <a:round/>
+                      <a:headEnd type="none" w="med" len="med"/>
+                      <a:tailEnd type="none" w="med" len="med"/>
+                    </a:lnL>
+                    <a:lnR w="12700" cap="flat" cmpd="sng" algn="ctr">
+                      <a:solidFill>
+                        <a:srgbClr val="475569"/>
+                      </a:solidFill>
+                      <a:prstDash val="solid"/>
+                      <a:round/>
+                      <a:headEnd type="none" w="med" len="med"/>
+                      <a:tailEnd type="none" w="med" len="med"/>
+                    </a:lnR>
+                    <a:lnT w="12700" cap="flat" cmpd="sng" algn="ctr">
+                      <a:solidFill>
+                        <a:srgbClr val="475569"/>
+                      </a:solidFill>
+                      <a:prstDash val="solid"/>
+                      <a:round/>
+                      <a:headEnd type="none" w="med" len="med"/>
+                      <a:tailEnd type="none" w="med" len="med"/>
+                    </a:lnT>
+                    <a:lnB w="12700" cap="flat" cmpd="sng" algn="ctr">
+                      <a:solidFill>
+                        <a:srgbClr val="475569"/>
+                      </a:solidFill>
+                      <a:prstDash val="solid"/>
+                      <a:round/>
+                      <a:headEnd type="none" w="med" len="med"/>
+                      <a:tailEnd type="none" w="med" len="med"/>
+                    </a:lnB>
+                    <a:solidFill>
+                      <a:srgbClr val="0F172A"/>
+                    </a:solidFill>
+                  </a:tcPr>
+                </a:tc>
+                <a:tc>
+                  <a:txBody>
+                    <a:bodyPr/>
+                    <a:lstStyle/>
+                    <a:p>
+                      <a:pPr algn="ctr" indent="0" marL="0">
+                        <a:buNone/>
+                      </a:pPr>
+                      <a:r>
+                        <a:rPr lang="en-US" sz="1400" dirty="0">
+                          <a:solidFill>
+                            <a:srgbClr val="E2E8F0"/>
+                          </a:solidFill>
+                          <a:latin typeface="Calibri" pitchFamily="34" charset="0"/>
+                          <a:ea typeface="Calibri" pitchFamily="34" charset="-122"/>
+                          <a:cs typeface="Calibri" pitchFamily="34" charset="-120"/>
+                        </a:rPr>
+                        <a:t>0.9969</a:t>
+                      </a:r>
+                      <a:endParaRPr lang="en-US" sz="1400" dirty="0">
+                        <a:latin typeface="Calibri" charset="0"/>
+                        <a:ea typeface="Calibri" charset="0"/>
+                        <a:cs typeface="Calibri" charset="0"/>
+                      </a:endParaRPr>
+                    </a:p>
+                  </a:txBody>
+                  <a:tcPr marL="91440" marR="91440" marT="45720" marB="45720" anchor="ctr">
+                    <a:lnL w="12700" cap="flat" cmpd="sng" algn="ctr">
+                      <a:solidFill>
+                        <a:srgbClr val="475569"/>
+                      </a:solidFill>
+                      <a:prstDash val="solid"/>
+                      <a:round/>
+                      <a:headEnd type="none" w="med" len="med"/>
+                      <a:tailEnd type="none" w="med" len="med"/>
+                    </a:lnL>
+                    <a:lnR w="12700" cap="flat" cmpd="sng" algn="ctr">
+                      <a:solidFill>
+                        <a:srgbClr val="475569"/>
+                      </a:solidFill>
+                      <a:prstDash val="solid"/>
+                      <a:round/>
+                      <a:headEnd type="none" w="med" len="med"/>
+                      <a:tailEnd type="none" w="med" len="med"/>
+                    </a:lnR>
+                    <a:lnT w="12700" cap="flat" cmpd="sng" algn="ctr">
+                      <a:solidFill>
+                        <a:srgbClr val="475569"/>
+                      </a:solidFill>
+                      <a:prstDash val="solid"/>
+                      <a:round/>
+                      <a:headEnd type="none" w="med" len="med"/>
+                      <a:tailEnd type="none" w="med" len="med"/>
+                    </a:lnT>
+                    <a:lnB w="12700" cap="flat" cmpd="sng" algn="ctr">
+                      <a:solidFill>
+                        <a:srgbClr val="475569"/>
+                      </a:solidFill>
+                      <a:prstDash val="solid"/>
+                      <a:round/>
+                      <a:headEnd type="none" w="med" len="med"/>
+                      <a:tailEnd type="none" w="med" len="med"/>
+                    </a:lnB>
+                    <a:solidFill>
+                      <a:srgbClr val="0F172A"/>
+                    </a:solidFill>
+                  </a:tcPr>
+                </a:tc>
+                <a:tc>
+                  <a:txBody>
+                    <a:bodyPr/>
+                    <a:lstStyle/>
+                    <a:p>
+                      <a:pPr algn="ctr" indent="0" marL="0">
+                        <a:buNone/>
+                      </a:pPr>
+                      <a:r>
+                        <a:rPr lang="en-US" sz="1400" dirty="0">
+                          <a:solidFill>
+                            <a:srgbClr val="E2E8F0"/>
+                          </a:solidFill>
+                          <a:latin typeface="Calibri" pitchFamily="34" charset="0"/>
+                          <a:ea typeface="Calibri" pitchFamily="34" charset="-122"/>
+                          <a:cs typeface="Calibri" pitchFamily="34" charset="-120"/>
+                        </a:rPr>
+                        <a:t>0.9969</a:t>
+                      </a:r>
+                      <a:endParaRPr lang="en-US" sz="1400" dirty="0">
+                        <a:latin typeface="Calibri" charset="0"/>
+                        <a:ea typeface="Calibri" charset="0"/>
+                        <a:cs typeface="Calibri" charset="0"/>
+                      </a:endParaRPr>
+                    </a:p>
+                  </a:txBody>
+                  <a:tcPr marL="91440" marR="91440" marT="45720" marB="45720" anchor="ctr">
+                    <a:lnL w="12700" cap="flat" cmpd="sng" algn="ctr">
+                      <a:solidFill>
+                        <a:srgbClr val="475569"/>
+                      </a:solidFill>
+                      <a:prstDash val="solid"/>
+                      <a:round/>
+                      <a:headEnd type="none" w="med" len="med"/>
+                      <a:tailEnd type="none" w="med" len="med"/>
+                    </a:lnL>
+                    <a:lnR w="12700" cap="flat" cmpd="sng" algn="ctr">
+                      <a:solidFill>
+                        <a:srgbClr val="475569"/>
+                      </a:solidFill>
+                      <a:prstDash val="solid"/>
+                      <a:round/>
+                      <a:headEnd type="none" w="med" len="med"/>
+                      <a:tailEnd type="none" w="med" len="med"/>
+                    </a:lnR>
+                    <a:lnT w="12700" cap="flat" cmpd="sng" algn="ctr">
+                      <a:solidFill>
+                        <a:srgbClr val="475569"/>
+                      </a:solidFill>
+                      <a:prstDash val="solid"/>
+                      <a:round/>
+                      <a:headEnd type="none" w="med" len="med"/>
+                      <a:tailEnd type="none" w="med" len="med"/>
+                    </a:lnT>
+                    <a:lnB w="12700" cap="flat" cmpd="sng" algn="ctr">
+                      <a:solidFill>
+                        <a:srgbClr val="475569"/>
+                      </a:solidFill>
+                      <a:prstDash val="solid"/>
+                      <a:round/>
+                      <a:headEnd type="none" w="med" len="med"/>
+                      <a:tailEnd type="none" w="med" len="med"/>
+                    </a:lnB>
+                    <a:solidFill>
+                      <a:srgbClr val="0F172A"/>
+                    </a:solidFill>
+                  </a:tcPr>
+                </a:tc>
+              </a:tr>
+              <a:tr h="326571">
                 <a:tc>
                   <a:txBody>
                     <a:bodyPr/>
@@ -6103,7 +6445,7 @@
                   </a:tcPr>
                 </a:tc>
               </a:tr>
-              <a:tr h="457200">
+              <a:tr h="326571">
                 <a:tc>
                   <a:txBody>
                     <a:bodyPr/>
@@ -6394,6 +6736,348 @@
                           <a:cs typeface="Calibri" pitchFamily="34" charset="-120"/>
                         </a:rPr>
                         <a:t>0.9969</a:t>
+                      </a:r>
+                      <a:endParaRPr lang="en-US" sz="1400" dirty="0">
+                        <a:latin typeface="Calibri" charset="0"/>
+                        <a:ea typeface="Calibri" charset="0"/>
+                        <a:cs typeface="Calibri" charset="0"/>
+                      </a:endParaRPr>
+                    </a:p>
+                  </a:txBody>
+                  <a:tcPr marL="91440" marR="91440" marT="45720" marB="45720" anchor="ctr">
+                    <a:lnL w="12700" cap="flat" cmpd="sng" algn="ctr">
+                      <a:solidFill>
+                        <a:srgbClr val="475569"/>
+                      </a:solidFill>
+                      <a:prstDash val="solid"/>
+                      <a:round/>
+                      <a:headEnd type="none" w="med" len="med"/>
+                      <a:tailEnd type="none" w="med" len="med"/>
+                    </a:lnL>
+                    <a:lnR w="12700" cap="flat" cmpd="sng" algn="ctr">
+                      <a:solidFill>
+                        <a:srgbClr val="475569"/>
+                      </a:solidFill>
+                      <a:prstDash val="solid"/>
+                      <a:round/>
+                      <a:headEnd type="none" w="med" len="med"/>
+                      <a:tailEnd type="none" w="med" len="med"/>
+                    </a:lnR>
+                    <a:lnT w="12700" cap="flat" cmpd="sng" algn="ctr">
+                      <a:solidFill>
+                        <a:srgbClr val="475569"/>
+                      </a:solidFill>
+                      <a:prstDash val="solid"/>
+                      <a:round/>
+                      <a:headEnd type="none" w="med" len="med"/>
+                      <a:tailEnd type="none" w="med" len="med"/>
+                    </a:lnT>
+                    <a:lnB w="12700" cap="flat" cmpd="sng" algn="ctr">
+                      <a:solidFill>
+                        <a:srgbClr val="475569"/>
+                      </a:solidFill>
+                      <a:prstDash val="solid"/>
+                      <a:round/>
+                      <a:headEnd type="none" w="med" len="med"/>
+                      <a:tailEnd type="none" w="med" len="med"/>
+                    </a:lnB>
+                    <a:solidFill>
+                      <a:srgbClr val="0F172A"/>
+                    </a:solidFill>
+                  </a:tcPr>
+                </a:tc>
+              </a:tr>
+              <a:tr h="326571">
+                <a:tc>
+                  <a:txBody>
+                    <a:bodyPr/>
+                    <a:lstStyle/>
+                    <a:p>
+                      <a:pPr indent="0" marL="0">
+                        <a:buNone/>
+                      </a:pPr>
+                      <a:r>
+                        <a:rPr lang="en-US" sz="1400" i="1" dirty="0">
+                          <a:solidFill>
+                            <a:srgbClr val="E2E8F0"/>
+                          </a:solidFill>
+                          <a:latin typeface="Calibri" pitchFamily="34" charset="0"/>
+                          <a:ea typeface="Calibri" pitchFamily="34" charset="-122"/>
+                          <a:cs typeface="Calibri" pitchFamily="34" charset="-120"/>
+                        </a:rPr>
+                        <a:t>YOLOv8 (est. from literature)</a:t>
+                      </a:r>
+                      <a:endParaRPr lang="en-US" sz="1400" dirty="0">
+                        <a:latin typeface="Calibri" charset="0"/>
+                        <a:ea typeface="Calibri" charset="0"/>
+                        <a:cs typeface="Calibri" charset="0"/>
+                      </a:endParaRPr>
+                    </a:p>
+                  </a:txBody>
+                  <a:tcPr marL="91440" marR="91440" marT="45720" marB="45720" anchor="ctr">
+                    <a:lnL w="12700" cap="flat" cmpd="sng" algn="ctr">
+                      <a:solidFill>
+                        <a:srgbClr val="475569"/>
+                      </a:solidFill>
+                      <a:prstDash val="solid"/>
+                      <a:round/>
+                      <a:headEnd type="none" w="med" len="med"/>
+                      <a:tailEnd type="none" w="med" len="med"/>
+                    </a:lnL>
+                    <a:lnR w="12700" cap="flat" cmpd="sng" algn="ctr">
+                      <a:solidFill>
+                        <a:srgbClr val="475569"/>
+                      </a:solidFill>
+                      <a:prstDash val="solid"/>
+                      <a:round/>
+                      <a:headEnd type="none" w="med" len="med"/>
+                      <a:tailEnd type="none" w="med" len="med"/>
+                    </a:lnR>
+                    <a:lnT w="12700" cap="flat" cmpd="sng" algn="ctr">
+                      <a:solidFill>
+                        <a:srgbClr val="475569"/>
+                      </a:solidFill>
+                      <a:prstDash val="solid"/>
+                      <a:round/>
+                      <a:headEnd type="none" w="med" len="med"/>
+                      <a:tailEnd type="none" w="med" len="med"/>
+                    </a:lnT>
+                    <a:lnB w="12700" cap="flat" cmpd="sng" algn="ctr">
+                      <a:solidFill>
+                        <a:srgbClr val="475569"/>
+                      </a:solidFill>
+                      <a:prstDash val="solid"/>
+                      <a:round/>
+                      <a:headEnd type="none" w="med" len="med"/>
+                      <a:tailEnd type="none" w="med" len="med"/>
+                    </a:lnB>
+                    <a:solidFill>
+                      <a:srgbClr val="0F172A"/>
+                    </a:solidFill>
+                  </a:tcPr>
+                </a:tc>
+                <a:tc>
+                  <a:txBody>
+                    <a:bodyPr/>
+                    <a:lstStyle/>
+                    <a:p>
+                      <a:pPr algn="ctr" indent="0" marL="0">
+                        <a:buNone/>
+                      </a:pPr>
+                      <a:r>
+                        <a:rPr lang="en-US" sz="1400" i="1" dirty="0">
+                          <a:solidFill>
+                            <a:srgbClr val="E2E8F0"/>
+                          </a:solidFill>
+                          <a:latin typeface="Calibri" pitchFamily="34" charset="0"/>
+                          <a:ea typeface="Calibri" pitchFamily="34" charset="-122"/>
+                          <a:cs typeface="Calibri" pitchFamily="34" charset="-120"/>
+                        </a:rPr>
+                        <a:t>~95-98%</a:t>
+                      </a:r>
+                      <a:endParaRPr lang="en-US" sz="1400" dirty="0">
+                        <a:latin typeface="Calibri" charset="0"/>
+                        <a:ea typeface="Calibri" charset="0"/>
+                        <a:cs typeface="Calibri" charset="0"/>
+                      </a:endParaRPr>
+                    </a:p>
+                  </a:txBody>
+                  <a:tcPr marL="91440" marR="91440" marT="45720" marB="45720" anchor="ctr">
+                    <a:lnL w="12700" cap="flat" cmpd="sng" algn="ctr">
+                      <a:solidFill>
+                        <a:srgbClr val="475569"/>
+                      </a:solidFill>
+                      <a:prstDash val="solid"/>
+                      <a:round/>
+                      <a:headEnd type="none" w="med" len="med"/>
+                      <a:tailEnd type="none" w="med" len="med"/>
+                    </a:lnL>
+                    <a:lnR w="12700" cap="flat" cmpd="sng" algn="ctr">
+                      <a:solidFill>
+                        <a:srgbClr val="475569"/>
+                      </a:solidFill>
+                      <a:prstDash val="solid"/>
+                      <a:round/>
+                      <a:headEnd type="none" w="med" len="med"/>
+                      <a:tailEnd type="none" w="med" len="med"/>
+                    </a:lnR>
+                    <a:lnT w="12700" cap="flat" cmpd="sng" algn="ctr">
+                      <a:solidFill>
+                        <a:srgbClr val="475569"/>
+                      </a:solidFill>
+                      <a:prstDash val="solid"/>
+                      <a:round/>
+                      <a:headEnd type="none" w="med" len="med"/>
+                      <a:tailEnd type="none" w="med" len="med"/>
+                    </a:lnT>
+                    <a:lnB w="12700" cap="flat" cmpd="sng" algn="ctr">
+                      <a:solidFill>
+                        <a:srgbClr val="475569"/>
+                      </a:solidFill>
+                      <a:prstDash val="solid"/>
+                      <a:round/>
+                      <a:headEnd type="none" w="med" len="med"/>
+                      <a:tailEnd type="none" w="med" len="med"/>
+                    </a:lnB>
+                    <a:solidFill>
+                      <a:srgbClr val="0F172A"/>
+                    </a:solidFill>
+                  </a:tcPr>
+                </a:tc>
+                <a:tc>
+                  <a:txBody>
+                    <a:bodyPr/>
+                    <a:lstStyle/>
+                    <a:p>
+                      <a:pPr algn="ctr" indent="0" marL="0">
+                        <a:buNone/>
+                      </a:pPr>
+                      <a:r>
+                        <a:rPr lang="en-US" sz="1400" i="1" dirty="0">
+                          <a:solidFill>
+                            <a:srgbClr val="E2E8F0"/>
+                          </a:solidFill>
+                          <a:latin typeface="Calibri" pitchFamily="34" charset="0"/>
+                          <a:ea typeface="Calibri" pitchFamily="34" charset="-122"/>
+                          <a:cs typeface="Calibri" pitchFamily="34" charset="-120"/>
+                        </a:rPr>
+                        <a:t>~0.96</a:t>
+                      </a:r>
+                      <a:endParaRPr lang="en-US" sz="1400" dirty="0">
+                        <a:latin typeface="Calibri" charset="0"/>
+                        <a:ea typeface="Calibri" charset="0"/>
+                        <a:cs typeface="Calibri" charset="0"/>
+                      </a:endParaRPr>
+                    </a:p>
+                  </a:txBody>
+                  <a:tcPr marL="91440" marR="91440" marT="45720" marB="45720" anchor="ctr">
+                    <a:lnL w="12700" cap="flat" cmpd="sng" algn="ctr">
+                      <a:solidFill>
+                        <a:srgbClr val="475569"/>
+                      </a:solidFill>
+                      <a:prstDash val="solid"/>
+                      <a:round/>
+                      <a:headEnd type="none" w="med" len="med"/>
+                      <a:tailEnd type="none" w="med" len="med"/>
+                    </a:lnL>
+                    <a:lnR w="12700" cap="flat" cmpd="sng" algn="ctr">
+                      <a:solidFill>
+                        <a:srgbClr val="475569"/>
+                      </a:solidFill>
+                      <a:prstDash val="solid"/>
+                      <a:round/>
+                      <a:headEnd type="none" w="med" len="med"/>
+                      <a:tailEnd type="none" w="med" len="med"/>
+                    </a:lnR>
+                    <a:lnT w="12700" cap="flat" cmpd="sng" algn="ctr">
+                      <a:solidFill>
+                        <a:srgbClr val="475569"/>
+                      </a:solidFill>
+                      <a:prstDash val="solid"/>
+                      <a:round/>
+                      <a:headEnd type="none" w="med" len="med"/>
+                      <a:tailEnd type="none" w="med" len="med"/>
+                    </a:lnT>
+                    <a:lnB w="12700" cap="flat" cmpd="sng" algn="ctr">
+                      <a:solidFill>
+                        <a:srgbClr val="475569"/>
+                      </a:solidFill>
+                      <a:prstDash val="solid"/>
+                      <a:round/>
+                      <a:headEnd type="none" w="med" len="med"/>
+                      <a:tailEnd type="none" w="med" len="med"/>
+                    </a:lnB>
+                    <a:solidFill>
+                      <a:srgbClr val="0F172A"/>
+                    </a:solidFill>
+                  </a:tcPr>
+                </a:tc>
+                <a:tc>
+                  <a:txBody>
+                    <a:bodyPr/>
+                    <a:lstStyle/>
+                    <a:p>
+                      <a:pPr algn="ctr" indent="0" marL="0">
+                        <a:buNone/>
+                      </a:pPr>
+                      <a:r>
+                        <a:rPr lang="en-US" sz="1400" i="1" dirty="0">
+                          <a:solidFill>
+                            <a:srgbClr val="E2E8F0"/>
+                          </a:solidFill>
+                          <a:latin typeface="Calibri" pitchFamily="34" charset="0"/>
+                          <a:ea typeface="Calibri" pitchFamily="34" charset="-122"/>
+                          <a:cs typeface="Calibri" pitchFamily="34" charset="-120"/>
+                        </a:rPr>
+                        <a:t>~0.96</a:t>
+                      </a:r>
+                      <a:endParaRPr lang="en-US" sz="1400" dirty="0">
+                        <a:latin typeface="Calibri" charset="0"/>
+                        <a:ea typeface="Calibri" charset="0"/>
+                        <a:cs typeface="Calibri" charset="0"/>
+                      </a:endParaRPr>
+                    </a:p>
+                  </a:txBody>
+                  <a:tcPr marL="91440" marR="91440" marT="45720" marB="45720" anchor="ctr">
+                    <a:lnL w="12700" cap="flat" cmpd="sng" algn="ctr">
+                      <a:solidFill>
+                        <a:srgbClr val="475569"/>
+                      </a:solidFill>
+                      <a:prstDash val="solid"/>
+                      <a:round/>
+                      <a:headEnd type="none" w="med" len="med"/>
+                      <a:tailEnd type="none" w="med" len="med"/>
+                    </a:lnL>
+                    <a:lnR w="12700" cap="flat" cmpd="sng" algn="ctr">
+                      <a:solidFill>
+                        <a:srgbClr val="475569"/>
+                      </a:solidFill>
+                      <a:prstDash val="solid"/>
+                      <a:round/>
+                      <a:headEnd type="none" w="med" len="med"/>
+                      <a:tailEnd type="none" w="med" len="med"/>
+                    </a:lnR>
+                    <a:lnT w="12700" cap="flat" cmpd="sng" algn="ctr">
+                      <a:solidFill>
+                        <a:srgbClr val="475569"/>
+                      </a:solidFill>
+                      <a:prstDash val="solid"/>
+                      <a:round/>
+                      <a:headEnd type="none" w="med" len="med"/>
+                      <a:tailEnd type="none" w="med" len="med"/>
+                    </a:lnT>
+                    <a:lnB w="12700" cap="flat" cmpd="sng" algn="ctr">
+                      <a:solidFill>
+                        <a:srgbClr val="475569"/>
+                      </a:solidFill>
+                      <a:prstDash val="solid"/>
+                      <a:round/>
+                      <a:headEnd type="none" w="med" len="med"/>
+                      <a:tailEnd type="none" w="med" len="med"/>
+                    </a:lnB>
+                    <a:solidFill>
+                      <a:srgbClr val="0F172A"/>
+                    </a:solidFill>
+                  </a:tcPr>
+                </a:tc>
+                <a:tc>
+                  <a:txBody>
+                    <a:bodyPr/>
+                    <a:lstStyle/>
+                    <a:p>
+                      <a:pPr algn="ctr" indent="0" marL="0">
+                        <a:buNone/>
+                      </a:pPr>
+                      <a:r>
+                        <a:rPr lang="en-US" sz="1400" i="1" dirty="0">
+                          <a:solidFill>
+                            <a:srgbClr val="E2E8F0"/>
+                          </a:solidFill>
+                          <a:latin typeface="Calibri" pitchFamily="34" charset="0"/>
+                          <a:ea typeface="Calibri" pitchFamily="34" charset="-122"/>
+                          <a:cs typeface="Calibri" pitchFamily="34" charset="-120"/>
+                        </a:rPr>
+                        <a:t>~0.96</a:t>
                       </a:r>
                       <a:endParaRPr lang="en-US" sz="1400" dirty="0">
                         <a:latin typeface="Calibri" charset="0"/>
@@ -12068,7 +12752,7 @@
                 <a:gridCol w="2743200"/>
                 <a:gridCol w="2286000"/>
               </a:tblGrid>
-              <a:tr h="274320">
+              <a:tr h="228600">
                 <a:tc>
                   <a:txBody>
                     <a:bodyPr/>
@@ -12274,7 +12958,7 @@
                   </a:tcPr>
                 </a:tc>
               </a:tr>
-              <a:tr h="274320">
+              <a:tr h="228600">
                 <a:tc>
                   <a:txBody>
                     <a:bodyPr/>
@@ -12360,7 +13044,7 @@
                           <a:ea typeface="Calibri" pitchFamily="34" charset="-122"/>
                           <a:cs typeface="Calibri" pitchFamily="34" charset="-120"/>
                         </a:rPr>
-                        <a:t>0.61 ms</a:t>
+                        <a:t>0.48 ms</a:t>
                       </a:r>
                       <a:endParaRPr lang="en-US" sz="1400" dirty="0">
                         <a:latin typeface="Calibri" charset="0"/>
@@ -12428,7 +13112,7 @@
                           <a:ea typeface="Calibri" pitchFamily="34" charset="-122"/>
                           <a:cs typeface="Calibri" pitchFamily="34" charset="-120"/>
                         </a:rPr>
-                        <a:t>1,597x faster</a:t>
+                        <a:t>12,760x faster</a:t>
                       </a:r>
                       <a:endParaRPr lang="en-US" sz="1400" dirty="0">
                         <a:latin typeface="Calibri" charset="0"/>
@@ -12480,7 +13164,7 @@
                   </a:tcPr>
                 </a:tc>
               </a:tr>
-              <a:tr h="274320">
+              <a:tr h="228600">
                 <a:tc>
                   <a:txBody>
                     <a:bodyPr/>
@@ -12566,7 +13250,7 @@
                           <a:ea typeface="Calibri" pitchFamily="34" charset="-122"/>
                           <a:cs typeface="Calibri" pitchFamily="34" charset="-120"/>
                         </a:rPr>
-                        <a:t>80.25 ms</a:t>
+                        <a:t>86.25 ms</a:t>
                       </a:r>
                       <a:endParaRPr lang="en-US" sz="1400" dirty="0">
                         <a:latin typeface="Calibri" charset="0"/>
@@ -12634,7 +13318,7 @@
                           <a:ea typeface="Calibri" pitchFamily="34" charset="-122"/>
                           <a:cs typeface="Calibri" pitchFamily="34" charset="-120"/>
                         </a:rPr>
-                        <a:t>12x</a:t>
+                        <a:t>71x</a:t>
                       </a:r>
                       <a:endParaRPr lang="en-US" sz="1400" dirty="0">
                         <a:latin typeface="Calibri" charset="0"/>
@@ -12686,213 +13370,7 @@
                   </a:tcPr>
                 </a:tc>
               </a:tr>
-              <a:tr h="274320">
-                <a:tc>
-                  <a:txBody>
-                    <a:bodyPr/>
-                    <a:lstStyle/>
-                    <a:p>
-                      <a:pPr indent="0" marL="0">
-                        <a:buNone/>
-                      </a:pPr>
-                      <a:r>
-                        <a:rPr lang="en-US" sz="1400" dirty="0">
-                          <a:solidFill>
-                            <a:srgbClr val="333333"/>
-                          </a:solidFill>
-                          <a:latin typeface="Calibri" pitchFamily="34" charset="0"/>
-                          <a:ea typeface="Calibri" pitchFamily="34" charset="-122"/>
-                          <a:cs typeface="Calibri" pitchFamily="34" charset="-120"/>
-                        </a:rPr>
-                        <a:t>Random Forest</a:t>
-                      </a:r>
-                      <a:endParaRPr lang="en-US" sz="1400" dirty="0">
-                        <a:latin typeface="Calibri" charset="0"/>
-                        <a:ea typeface="Calibri" charset="0"/>
-                        <a:cs typeface="Calibri" charset="0"/>
-                      </a:endParaRPr>
-                    </a:p>
-                  </a:txBody>
-                  <a:tcPr marL="91440" marR="91440" marT="45720" marB="45720" anchor="ctr">
-                    <a:lnL w="12700" cap="flat" cmpd="sng" algn="ctr">
-                      <a:solidFill>
-                        <a:srgbClr val="CBD5E1"/>
-                      </a:solidFill>
-                      <a:prstDash val="solid"/>
-                      <a:round/>
-                      <a:headEnd type="none" w="med" len="med"/>
-                      <a:tailEnd type="none" w="med" len="med"/>
-                    </a:lnL>
-                    <a:lnR w="12700" cap="flat" cmpd="sng" algn="ctr">
-                      <a:solidFill>
-                        <a:srgbClr val="CBD5E1"/>
-                      </a:solidFill>
-                      <a:prstDash val="solid"/>
-                      <a:round/>
-                      <a:headEnd type="none" w="med" len="med"/>
-                      <a:tailEnd type="none" w="med" len="med"/>
-                    </a:lnR>
-                    <a:lnT w="12700" cap="flat" cmpd="sng" algn="ctr">
-                      <a:solidFill>
-                        <a:srgbClr val="CBD5E1"/>
-                      </a:solidFill>
-                      <a:prstDash val="solid"/>
-                      <a:round/>
-                      <a:headEnd type="none" w="med" len="med"/>
-                      <a:tailEnd type="none" w="med" len="med"/>
-                    </a:lnT>
-                    <a:lnB w="12700" cap="flat" cmpd="sng" algn="ctr">
-                      <a:solidFill>
-                        <a:srgbClr val="CBD5E1"/>
-                      </a:solidFill>
-                      <a:prstDash val="solid"/>
-                      <a:round/>
-                      <a:headEnd type="none" w="med" len="med"/>
-                      <a:tailEnd type="none" w="med" len="med"/>
-                    </a:lnB>
-                    <a:solidFill>
-                      <a:srgbClr val="F8FAFC"/>
-                    </a:solidFill>
-                  </a:tcPr>
-                </a:tc>
-                <a:tc>
-                  <a:txBody>
-                    <a:bodyPr/>
-                    <a:lstStyle/>
-                    <a:p>
-                      <a:pPr algn="ctr" indent="0" marL="0">
-                        <a:buNone/>
-                      </a:pPr>
-                      <a:r>
-                        <a:rPr lang="en-US" sz="1400" dirty="0">
-                          <a:solidFill>
-                            <a:srgbClr val="333333"/>
-                          </a:solidFill>
-                          <a:latin typeface="Calibri" pitchFamily="34" charset="0"/>
-                          <a:ea typeface="Calibri" pitchFamily="34" charset="-122"/>
-                          <a:cs typeface="Calibri" pitchFamily="34" charset="-120"/>
-                        </a:rPr>
-                        <a:t>375.56 ms</a:t>
-                      </a:r>
-                      <a:endParaRPr lang="en-US" sz="1400" dirty="0">
-                        <a:latin typeface="Calibri" charset="0"/>
-                        <a:ea typeface="Calibri" charset="0"/>
-                        <a:cs typeface="Calibri" charset="0"/>
-                      </a:endParaRPr>
-                    </a:p>
-                  </a:txBody>
-                  <a:tcPr marL="91440" marR="91440" marT="45720" marB="45720" anchor="ctr">
-                    <a:lnL w="12700" cap="flat" cmpd="sng" algn="ctr">
-                      <a:solidFill>
-                        <a:srgbClr val="CBD5E1"/>
-                      </a:solidFill>
-                      <a:prstDash val="solid"/>
-                      <a:round/>
-                      <a:headEnd type="none" w="med" len="med"/>
-                      <a:tailEnd type="none" w="med" len="med"/>
-                    </a:lnL>
-                    <a:lnR w="12700" cap="flat" cmpd="sng" algn="ctr">
-                      <a:solidFill>
-                        <a:srgbClr val="CBD5E1"/>
-                      </a:solidFill>
-                      <a:prstDash val="solid"/>
-                      <a:round/>
-                      <a:headEnd type="none" w="med" len="med"/>
-                      <a:tailEnd type="none" w="med" len="med"/>
-                    </a:lnR>
-                    <a:lnT w="12700" cap="flat" cmpd="sng" algn="ctr">
-                      <a:solidFill>
-                        <a:srgbClr val="CBD5E1"/>
-                      </a:solidFill>
-                      <a:prstDash val="solid"/>
-                      <a:round/>
-                      <a:headEnd type="none" w="med" len="med"/>
-                      <a:tailEnd type="none" w="med" len="med"/>
-                    </a:lnT>
-                    <a:lnB w="12700" cap="flat" cmpd="sng" algn="ctr">
-                      <a:solidFill>
-                        <a:srgbClr val="CBD5E1"/>
-                      </a:solidFill>
-                      <a:prstDash val="solid"/>
-                      <a:round/>
-                      <a:headEnd type="none" w="med" len="med"/>
-                      <a:tailEnd type="none" w="med" len="med"/>
-                    </a:lnB>
-                    <a:solidFill>
-                      <a:srgbClr val="F8FAFC"/>
-                    </a:solidFill>
-                  </a:tcPr>
-                </a:tc>
-                <a:tc>
-                  <a:txBody>
-                    <a:bodyPr/>
-                    <a:lstStyle/>
-                    <a:p>
-                      <a:pPr algn="ctr" indent="0" marL="0">
-                        <a:buNone/>
-                      </a:pPr>
-                      <a:r>
-                        <a:rPr lang="en-US" sz="1400" dirty="0">
-                          <a:solidFill>
-                            <a:srgbClr val="333333"/>
-                          </a:solidFill>
-                          <a:latin typeface="Calibri" pitchFamily="34" charset="0"/>
-                          <a:ea typeface="Calibri" pitchFamily="34" charset="-122"/>
-                          <a:cs typeface="Calibri" pitchFamily="34" charset="-120"/>
-                        </a:rPr>
-                        <a:t>3x</a:t>
-                      </a:r>
-                      <a:endParaRPr lang="en-US" sz="1400" dirty="0">
-                        <a:latin typeface="Calibri" charset="0"/>
-                        <a:ea typeface="Calibri" charset="0"/>
-                        <a:cs typeface="Calibri" charset="0"/>
-                      </a:endParaRPr>
-                    </a:p>
-                  </a:txBody>
-                  <a:tcPr marL="91440" marR="91440" marT="45720" marB="45720" anchor="ctr">
-                    <a:lnL w="12700" cap="flat" cmpd="sng" algn="ctr">
-                      <a:solidFill>
-                        <a:srgbClr val="CBD5E1"/>
-                      </a:solidFill>
-                      <a:prstDash val="solid"/>
-                      <a:round/>
-                      <a:headEnd type="none" w="med" len="med"/>
-                      <a:tailEnd type="none" w="med" len="med"/>
-                    </a:lnL>
-                    <a:lnR w="12700" cap="flat" cmpd="sng" algn="ctr">
-                      <a:solidFill>
-                        <a:srgbClr val="CBD5E1"/>
-                      </a:solidFill>
-                      <a:prstDash val="solid"/>
-                      <a:round/>
-                      <a:headEnd type="none" w="med" len="med"/>
-                      <a:tailEnd type="none" w="med" len="med"/>
-                    </a:lnR>
-                    <a:lnT w="12700" cap="flat" cmpd="sng" algn="ctr">
-                      <a:solidFill>
-                        <a:srgbClr val="CBD5E1"/>
-                      </a:solidFill>
-                      <a:prstDash val="solid"/>
-                      <a:round/>
-                      <a:headEnd type="none" w="med" len="med"/>
-                      <a:tailEnd type="none" w="med" len="med"/>
-                    </a:lnT>
-                    <a:lnB w="12700" cap="flat" cmpd="sng" algn="ctr">
-                      <a:solidFill>
-                        <a:srgbClr val="CBD5E1"/>
-                      </a:solidFill>
-                      <a:prstDash val="solid"/>
-                      <a:round/>
-                      <a:headEnd type="none" w="med" len="med"/>
-                      <a:tailEnd type="none" w="med" len="med"/>
-                    </a:lnB>
-                    <a:solidFill>
-                      <a:srgbClr val="F8FAFC"/>
-                    </a:solidFill>
-                  </a:tcPr>
-                </a:tc>
-              </a:tr>
-              <a:tr h="274320">
+              <a:tr h="228600">
                 <a:tc>
                   <a:txBody>
                     <a:bodyPr/>
@@ -12972,13 +13450,151 @@
                       <a:r>
                         <a:rPr lang="en-US" sz="1400" dirty="0">
                           <a:solidFill>
-                            <a:srgbClr val="EF4444"/>
+                            <a:srgbClr val="333333"/>
                           </a:solidFill>
                           <a:latin typeface="Calibri" pitchFamily="34" charset="0"/>
                           <a:ea typeface="Calibri" pitchFamily="34" charset="-122"/>
                           <a:cs typeface="Calibri" pitchFamily="34" charset="-120"/>
                         </a:rPr>
-                        <a:t>979.10 ms</a:t>
+                        <a:t>2,600 ms</a:t>
+                      </a:r>
+                      <a:endParaRPr lang="en-US" sz="1400" dirty="0">
+                        <a:latin typeface="Calibri" charset="0"/>
+                        <a:ea typeface="Calibri" charset="0"/>
+                        <a:cs typeface="Calibri" charset="0"/>
+                      </a:endParaRPr>
+                    </a:p>
+                  </a:txBody>
+                  <a:tcPr marL="91440" marR="91440" marT="45720" marB="45720" anchor="ctr">
+                    <a:lnL w="12700" cap="flat" cmpd="sng" algn="ctr">
+                      <a:solidFill>
+                        <a:srgbClr val="CBD5E1"/>
+                      </a:solidFill>
+                      <a:prstDash val="solid"/>
+                      <a:round/>
+                      <a:headEnd type="none" w="med" len="med"/>
+                      <a:tailEnd type="none" w="med" len="med"/>
+                    </a:lnL>
+                    <a:lnR w="12700" cap="flat" cmpd="sng" algn="ctr">
+                      <a:solidFill>
+                        <a:srgbClr val="CBD5E1"/>
+                      </a:solidFill>
+                      <a:prstDash val="solid"/>
+                      <a:round/>
+                      <a:headEnd type="none" w="med" len="med"/>
+                      <a:tailEnd type="none" w="med" len="med"/>
+                    </a:lnR>
+                    <a:lnT w="12700" cap="flat" cmpd="sng" algn="ctr">
+                      <a:solidFill>
+                        <a:srgbClr val="CBD5E1"/>
+                      </a:solidFill>
+                      <a:prstDash val="solid"/>
+                      <a:round/>
+                      <a:headEnd type="none" w="med" len="med"/>
+                      <a:tailEnd type="none" w="med" len="med"/>
+                    </a:lnT>
+                    <a:lnB w="12700" cap="flat" cmpd="sng" algn="ctr">
+                      <a:solidFill>
+                        <a:srgbClr val="CBD5E1"/>
+                      </a:solidFill>
+                      <a:prstDash val="solid"/>
+                      <a:round/>
+                      <a:headEnd type="none" w="med" len="med"/>
+                      <a:tailEnd type="none" w="med" len="med"/>
+                    </a:lnB>
+                    <a:solidFill>
+                      <a:srgbClr val="F8FAFC"/>
+                    </a:solidFill>
+                  </a:tcPr>
+                </a:tc>
+                <a:tc>
+                  <a:txBody>
+                    <a:bodyPr/>
+                    <a:lstStyle/>
+                    <a:p>
+                      <a:pPr algn="ctr" indent="0" marL="0">
+                        <a:buNone/>
+                      </a:pPr>
+                      <a:r>
+                        <a:rPr lang="en-US" sz="1400" dirty="0">
+                          <a:solidFill>
+                            <a:srgbClr val="333333"/>
+                          </a:solidFill>
+                          <a:latin typeface="Calibri" pitchFamily="34" charset="0"/>
+                          <a:ea typeface="Calibri" pitchFamily="34" charset="-122"/>
+                          <a:cs typeface="Calibri" pitchFamily="34" charset="-120"/>
+                        </a:rPr>
+                        <a:t>2.4x</a:t>
+                      </a:r>
+                      <a:endParaRPr lang="en-US" sz="1400" dirty="0">
+                        <a:latin typeface="Calibri" charset="0"/>
+                        <a:ea typeface="Calibri" charset="0"/>
+                        <a:cs typeface="Calibri" charset="0"/>
+                      </a:endParaRPr>
+                    </a:p>
+                  </a:txBody>
+                  <a:tcPr marL="91440" marR="91440" marT="45720" marB="45720" anchor="ctr">
+                    <a:lnL w="12700" cap="flat" cmpd="sng" algn="ctr">
+                      <a:solidFill>
+                        <a:srgbClr val="CBD5E1"/>
+                      </a:solidFill>
+                      <a:prstDash val="solid"/>
+                      <a:round/>
+                      <a:headEnd type="none" w="med" len="med"/>
+                      <a:tailEnd type="none" w="med" len="med"/>
+                    </a:lnL>
+                    <a:lnR w="12700" cap="flat" cmpd="sng" algn="ctr">
+                      <a:solidFill>
+                        <a:srgbClr val="CBD5E1"/>
+                      </a:solidFill>
+                      <a:prstDash val="solid"/>
+                      <a:round/>
+                      <a:headEnd type="none" w="med" len="med"/>
+                      <a:tailEnd type="none" w="med" len="med"/>
+                    </a:lnR>
+                    <a:lnT w="12700" cap="flat" cmpd="sng" algn="ctr">
+                      <a:solidFill>
+                        <a:srgbClr val="CBD5E1"/>
+                      </a:solidFill>
+                      <a:prstDash val="solid"/>
+                      <a:round/>
+                      <a:headEnd type="none" w="med" len="med"/>
+                      <a:tailEnd type="none" w="med" len="med"/>
+                    </a:lnT>
+                    <a:lnB w="12700" cap="flat" cmpd="sng" algn="ctr">
+                      <a:solidFill>
+                        <a:srgbClr val="CBD5E1"/>
+                      </a:solidFill>
+                      <a:prstDash val="solid"/>
+                      <a:round/>
+                      <a:headEnd type="none" w="med" len="med"/>
+                      <a:tailEnd type="none" w="med" len="med"/>
+                    </a:lnB>
+                    <a:solidFill>
+                      <a:srgbClr val="F8FAFC"/>
+                    </a:solidFill>
+                  </a:tcPr>
+                </a:tc>
+              </a:tr>
+              <a:tr h="228600">
+                <a:tc>
+                  <a:txBody>
+                    <a:bodyPr/>
+                    <a:lstStyle/>
+                    <a:p>
+                      <a:pPr indent="0" marL="0">
+                        <a:buNone/>
+                      </a:pPr>
+                      <a:r>
+                        <a:rPr lang="en-US" sz="1400" dirty="0">
+                          <a:solidFill>
+                            <a:srgbClr val="333333"/>
+                          </a:solidFill>
+                          <a:latin typeface="Calibri" pitchFamily="34" charset="0"/>
+                          <a:ea typeface="Calibri" pitchFamily="34" charset="-122"/>
+                          <a:cs typeface="Calibri" pitchFamily="34" charset="-120"/>
+                        </a:rPr>
+                        <a:t>ResNet18 Classifier</a:t>
                       </a:r>
                       <a:endParaRPr lang="en-US" sz="1400" dirty="0">
                         <a:latin typeface="Calibri" charset="0"/>
@@ -13046,7 +13662,281 @@
                           <a:ea typeface="Calibri" pitchFamily="34" charset="-122"/>
                           <a:cs typeface="Calibri" pitchFamily="34" charset="-120"/>
                         </a:rPr>
-                        <a:t>1x (slowest)</a:t>
+                        <a:t>6,125 ms</a:t>
+                      </a:r>
+                      <a:endParaRPr lang="en-US" sz="1400" dirty="0">
+                        <a:latin typeface="Calibri" charset="0"/>
+                        <a:ea typeface="Calibri" charset="0"/>
+                        <a:cs typeface="Calibri" charset="0"/>
+                      </a:endParaRPr>
+                    </a:p>
+                  </a:txBody>
+                  <a:tcPr marL="91440" marR="91440" marT="45720" marB="45720" anchor="ctr">
+                    <a:lnL w="12700" cap="flat" cmpd="sng" algn="ctr">
+                      <a:solidFill>
+                        <a:srgbClr val="CBD5E1"/>
+                      </a:solidFill>
+                      <a:prstDash val="solid"/>
+                      <a:round/>
+                      <a:headEnd type="none" w="med" len="med"/>
+                      <a:tailEnd type="none" w="med" len="med"/>
+                    </a:lnL>
+                    <a:lnR w="12700" cap="flat" cmpd="sng" algn="ctr">
+                      <a:solidFill>
+                        <a:srgbClr val="CBD5E1"/>
+                      </a:solidFill>
+                      <a:prstDash val="solid"/>
+                      <a:round/>
+                      <a:headEnd type="none" w="med" len="med"/>
+                      <a:tailEnd type="none" w="med" len="med"/>
+                    </a:lnR>
+                    <a:lnT w="12700" cap="flat" cmpd="sng" algn="ctr">
+                      <a:solidFill>
+                        <a:srgbClr val="CBD5E1"/>
+                      </a:solidFill>
+                      <a:prstDash val="solid"/>
+                      <a:round/>
+                      <a:headEnd type="none" w="med" len="med"/>
+                      <a:tailEnd type="none" w="med" len="med"/>
+                    </a:lnT>
+                    <a:lnB w="12700" cap="flat" cmpd="sng" algn="ctr">
+                      <a:solidFill>
+                        <a:srgbClr val="CBD5E1"/>
+                      </a:solidFill>
+                      <a:prstDash val="solid"/>
+                      <a:round/>
+                      <a:headEnd type="none" w="med" len="med"/>
+                      <a:tailEnd type="none" w="med" len="med"/>
+                    </a:lnB>
+                    <a:solidFill>
+                      <a:srgbClr val="F8FAFC"/>
+                    </a:solidFill>
+                  </a:tcPr>
+                </a:tc>
+                <a:tc>
+                  <a:txBody>
+                    <a:bodyPr/>
+                    <a:lstStyle/>
+                    <a:p>
+                      <a:pPr algn="ctr" indent="0" marL="0">
+                        <a:buNone/>
+                      </a:pPr>
+                      <a:r>
+                        <a:rPr lang="en-US" sz="1400" dirty="0">
+                          <a:solidFill>
+                            <a:srgbClr val="EF4444"/>
+                          </a:solidFill>
+                          <a:latin typeface="Calibri" pitchFamily="34" charset="0"/>
+                          <a:ea typeface="Calibri" pitchFamily="34" charset="-122"/>
+                          <a:cs typeface="Calibri" pitchFamily="34" charset="-120"/>
+                        </a:rPr>
+                        <a:t>1x</a:t>
+                      </a:r>
+                      <a:endParaRPr lang="en-US" sz="1400" dirty="0">
+                        <a:latin typeface="Calibri" charset="0"/>
+                        <a:ea typeface="Calibri" charset="0"/>
+                        <a:cs typeface="Calibri" charset="0"/>
+                      </a:endParaRPr>
+                    </a:p>
+                  </a:txBody>
+                  <a:tcPr marL="91440" marR="91440" marT="45720" marB="45720" anchor="ctr">
+                    <a:lnL w="12700" cap="flat" cmpd="sng" algn="ctr">
+                      <a:solidFill>
+                        <a:srgbClr val="CBD5E1"/>
+                      </a:solidFill>
+                      <a:prstDash val="solid"/>
+                      <a:round/>
+                      <a:headEnd type="none" w="med" len="med"/>
+                      <a:tailEnd type="none" w="med" len="med"/>
+                    </a:lnL>
+                    <a:lnR w="12700" cap="flat" cmpd="sng" algn="ctr">
+                      <a:solidFill>
+                        <a:srgbClr val="CBD5E1"/>
+                      </a:solidFill>
+                      <a:prstDash val="solid"/>
+                      <a:round/>
+                      <a:headEnd type="none" w="med" len="med"/>
+                      <a:tailEnd type="none" w="med" len="med"/>
+                    </a:lnR>
+                    <a:lnT w="12700" cap="flat" cmpd="sng" algn="ctr">
+                      <a:solidFill>
+                        <a:srgbClr val="CBD5E1"/>
+                      </a:solidFill>
+                      <a:prstDash val="solid"/>
+                      <a:round/>
+                      <a:headEnd type="none" w="med" len="med"/>
+                      <a:tailEnd type="none" w="med" len="med"/>
+                    </a:lnT>
+                    <a:lnB w="12700" cap="flat" cmpd="sng" algn="ctr">
+                      <a:solidFill>
+                        <a:srgbClr val="CBD5E1"/>
+                      </a:solidFill>
+                      <a:prstDash val="solid"/>
+                      <a:round/>
+                      <a:headEnd type="none" w="med" len="med"/>
+                      <a:tailEnd type="none" w="med" len="med"/>
+                    </a:lnB>
+                    <a:solidFill>
+                      <a:srgbClr val="F8FAFC"/>
+                    </a:solidFill>
+                  </a:tcPr>
+                </a:tc>
+              </a:tr>
+              <a:tr h="228600">
+                <a:tc>
+                  <a:txBody>
+                    <a:bodyPr/>
+                    <a:lstStyle/>
+                    <a:p>
+                      <a:pPr indent="0" marL="0">
+                        <a:buNone/>
+                      </a:pPr>
+                      <a:r>
+                        <a:rPr lang="en-US" sz="1400" i="1" dirty="0">
+                          <a:solidFill>
+                            <a:srgbClr val="333333"/>
+                          </a:solidFill>
+                          <a:latin typeface="Calibri" pitchFamily="34" charset="0"/>
+                          <a:ea typeface="Calibri" pitchFamily="34" charset="-122"/>
+                          <a:cs typeface="Calibri" pitchFamily="34" charset="-120"/>
+                        </a:rPr>
+                        <a:t>YOLOv8 (full retrain)</a:t>
+                      </a:r>
+                      <a:endParaRPr lang="en-US" sz="1400" dirty="0">
+                        <a:latin typeface="Calibri" charset="0"/>
+                        <a:ea typeface="Calibri" charset="0"/>
+                        <a:cs typeface="Calibri" charset="0"/>
+                      </a:endParaRPr>
+                    </a:p>
+                  </a:txBody>
+                  <a:tcPr marL="91440" marR="91440" marT="45720" marB="45720" anchor="ctr">
+                    <a:lnL w="12700" cap="flat" cmpd="sng" algn="ctr">
+                      <a:solidFill>
+                        <a:srgbClr val="CBD5E1"/>
+                      </a:solidFill>
+                      <a:prstDash val="solid"/>
+                      <a:round/>
+                      <a:headEnd type="none" w="med" len="med"/>
+                      <a:tailEnd type="none" w="med" len="med"/>
+                    </a:lnL>
+                    <a:lnR w="12700" cap="flat" cmpd="sng" algn="ctr">
+                      <a:solidFill>
+                        <a:srgbClr val="CBD5E1"/>
+                      </a:solidFill>
+                      <a:prstDash val="solid"/>
+                      <a:round/>
+                      <a:headEnd type="none" w="med" len="med"/>
+                      <a:tailEnd type="none" w="med" len="med"/>
+                    </a:lnR>
+                    <a:lnT w="12700" cap="flat" cmpd="sng" algn="ctr">
+                      <a:solidFill>
+                        <a:srgbClr val="CBD5E1"/>
+                      </a:solidFill>
+                      <a:prstDash val="solid"/>
+                      <a:round/>
+                      <a:headEnd type="none" w="med" len="med"/>
+                      <a:tailEnd type="none" w="med" len="med"/>
+                    </a:lnT>
+                    <a:lnB w="12700" cap="flat" cmpd="sng" algn="ctr">
+                      <a:solidFill>
+                        <a:srgbClr val="CBD5E1"/>
+                      </a:solidFill>
+                      <a:prstDash val="solid"/>
+                      <a:round/>
+                      <a:headEnd type="none" w="med" len="med"/>
+                      <a:tailEnd type="none" w="med" len="med"/>
+                    </a:lnB>
+                    <a:solidFill>
+                      <a:srgbClr val="F8FAFC"/>
+                    </a:solidFill>
+                  </a:tcPr>
+                </a:tc>
+                <a:tc>
+                  <a:txBody>
+                    <a:bodyPr/>
+                    <a:lstStyle/>
+                    <a:p>
+                      <a:pPr algn="ctr" indent="0" marL="0">
+                        <a:buNone/>
+                      </a:pPr>
+                      <a:r>
+                        <a:rPr lang="en-US" sz="1400" i="1" dirty="0">
+                          <a:solidFill>
+                            <a:srgbClr val="EF4444"/>
+                          </a:solidFill>
+                          <a:latin typeface="Calibri" pitchFamily="34" charset="0"/>
+                          <a:ea typeface="Calibri" pitchFamily="34" charset="-122"/>
+                          <a:cs typeface="Calibri" pitchFamily="34" charset="-120"/>
+                        </a:rPr>
+                        <a:t>~300,000 ms</a:t>
+                      </a:r>
+                      <a:endParaRPr lang="en-US" sz="1400" dirty="0">
+                        <a:latin typeface="Calibri" charset="0"/>
+                        <a:ea typeface="Calibri" charset="0"/>
+                        <a:cs typeface="Calibri" charset="0"/>
+                      </a:endParaRPr>
+                    </a:p>
+                  </a:txBody>
+                  <a:tcPr marL="91440" marR="91440" marT="45720" marB="45720" anchor="ctr">
+                    <a:lnL w="12700" cap="flat" cmpd="sng" algn="ctr">
+                      <a:solidFill>
+                        <a:srgbClr val="CBD5E1"/>
+                      </a:solidFill>
+                      <a:prstDash val="solid"/>
+                      <a:round/>
+                      <a:headEnd type="none" w="med" len="med"/>
+                      <a:tailEnd type="none" w="med" len="med"/>
+                    </a:lnL>
+                    <a:lnR w="12700" cap="flat" cmpd="sng" algn="ctr">
+                      <a:solidFill>
+                        <a:srgbClr val="CBD5E1"/>
+                      </a:solidFill>
+                      <a:prstDash val="solid"/>
+                      <a:round/>
+                      <a:headEnd type="none" w="med" len="med"/>
+                      <a:tailEnd type="none" w="med" len="med"/>
+                    </a:lnR>
+                    <a:lnT w="12700" cap="flat" cmpd="sng" algn="ctr">
+                      <a:solidFill>
+                        <a:srgbClr val="CBD5E1"/>
+                      </a:solidFill>
+                      <a:prstDash val="solid"/>
+                      <a:round/>
+                      <a:headEnd type="none" w="med" len="med"/>
+                      <a:tailEnd type="none" w="med" len="med"/>
+                    </a:lnT>
+                    <a:lnB w="12700" cap="flat" cmpd="sng" algn="ctr">
+                      <a:solidFill>
+                        <a:srgbClr val="CBD5E1"/>
+                      </a:solidFill>
+                      <a:prstDash val="solid"/>
+                      <a:round/>
+                      <a:headEnd type="none" w="med" len="med"/>
+                      <a:tailEnd type="none" w="med" len="med"/>
+                    </a:lnB>
+                    <a:solidFill>
+                      <a:srgbClr val="F8FAFC"/>
+                    </a:solidFill>
+                  </a:tcPr>
+                </a:tc>
+                <a:tc>
+                  <a:txBody>
+                    <a:bodyPr/>
+                    <a:lstStyle/>
+                    <a:p>
+                      <a:pPr algn="ctr" indent="0" marL="0">
+                        <a:buNone/>
+                      </a:pPr>
+                      <a:r>
+                        <a:rPr lang="en-US" sz="1400" i="1" dirty="0">
+                          <a:solidFill>
+                            <a:srgbClr val="EF4444"/>
+                          </a:solidFill>
+                          <a:latin typeface="Calibri" pitchFamily="34" charset="0"/>
+                          <a:ea typeface="Calibri" pitchFamily="34" charset="-122"/>
+                          <a:cs typeface="Calibri" pitchFamily="34" charset="-120"/>
+                        </a:rPr>
+                        <a:t>~5 min</a:t>
                       </a:r>
                       <a:endParaRPr lang="en-US" sz="1400" dirty="0">
                         <a:latin typeface="Calibri" charset="0"/>

</xml_diff>